<commit_message>
summary and outline added
</commit_message>
<xml_diff>
--- a/chapter 15.pptx
+++ b/chapter 15.pptx
@@ -248,7 +248,7 @@
           <a:p>
             <a:fld id="{13928E3B-7122-43E6-B3BB-09448C56C96C}" type="datetimeFigureOut">
               <a:rPr lang="en-US" smtClean="0"/>
-              <a:t>25/07/20</a:t>
+              <a:t>25/07/25</a:t>
             </a:fld>
             <a:endParaRPr lang="en-US"/>
           </a:p>
@@ -426,7 +426,7 @@
           <a:p>
             <a:fld id="{B98C9CAF-43DF-44BF-8016-DC193E4E594B}" type="datetimeFigureOut">
               <a:rPr lang="en-US" smtClean="0"/>
-              <a:t>25/07/20</a:t>
+              <a:t>25/07/25</a:t>
             </a:fld>
             <a:endParaRPr lang="en-US"/>
           </a:p>
@@ -3892,7 +3892,7 @@
           <a:p>
             <a:r>
               <a:rPr lang="en-US" dirty="0"/>
-              <a:t>15.2 Designing an Interface</a:t>
+              <a:t>Designing an Interface</a:t>
             </a:r>
           </a:p>
         </p:txBody>
@@ -4059,7 +4059,7 @@
           <a:p>
             <a:r>
               <a:rPr lang="en-US" dirty="0"/>
-              <a:t>15.2 Designing an Interface</a:t>
+              <a:t>Designing an Interface</a:t>
             </a:r>
           </a:p>
         </p:txBody>
@@ -5785,7 +5785,7 @@
           <a:p>
             <a:r>
               <a:rPr lang="en-US" dirty="0"/>
-              <a:t>15.3 Documenting the Interface</a:t>
+              <a:t>Documenting the Interface</a:t>
             </a:r>
           </a:p>
         </p:txBody>
@@ -5871,7 +5871,40 @@
           <a:bodyPr/>
           <a:lstStyle/>
           <a:p>
-            <a:endParaRPr lang="en-US"/>
+            <a:r>
+              <a:rPr lang="en-US" dirty="0"/>
+              <a:t>Architectural elements have interfaces, which are boundaries over which elements interact with each other. Interface design is an architectural duty.</a:t>
+            </a:r>
+          </a:p>
+          <a:p>
+            <a:r>
+              <a:rPr lang="en-US" dirty="0"/>
+              <a:t>A primary use of an interface is to encapsulate an element’s implementation, so that this implementation may change without affecting other elements.</a:t>
+            </a:r>
+          </a:p>
+          <a:p>
+            <a:r>
+              <a:rPr lang="en-US" dirty="0"/>
+              <a:t>Elements may have multiple interfaces, providing different types of access and privileges to different classes of actors.</a:t>
+            </a:r>
+          </a:p>
+          <a:p>
+            <a:r>
+              <a:rPr lang="en-US" dirty="0"/>
+              <a:t>Interfaces have operations, events, and properties; these are the parts of an interface that the architect can design. </a:t>
+            </a:r>
+          </a:p>
+          <a:p>
+            <a:r>
+              <a:rPr lang="en-US" dirty="0"/>
+              <a:t>Three techniques for changing an interface: deprecation, versioning, and extension.</a:t>
+            </a:r>
+          </a:p>
+          <a:p>
+            <a:r>
+              <a:rPr lang="en-US" dirty="0"/>
+              <a:t>The interface should be documented to and it must include what other developers need to know about an interface to use it in combination with other elements.</a:t>
+            </a:r>
           </a:p>
         </p:txBody>
       </p:sp>
@@ -5897,7 +5930,7 @@
           <a:lstStyle/>
           <a:p>
             <a:r>
-              <a:rPr lang="en-US"/>
+              <a:rPr lang="en-US" dirty="0"/>
               <a:t>Summary</a:t>
             </a:r>
           </a:p>
@@ -6210,7 +6243,136 @@
           <a:bodyPr/>
           <a:lstStyle/>
           <a:p>
-            <a:endParaRPr lang="en-US"/>
+            <a:pPr>
+              <a:spcBef>
+                <a:spcPts val="1200"/>
+              </a:spcBef>
+            </a:pPr>
+            <a:r>
+              <a:rPr lang="en-US" dirty="0"/>
+              <a:t>Introduction</a:t>
+            </a:r>
+          </a:p>
+          <a:p>
+            <a:pPr>
+              <a:spcBef>
+                <a:spcPts val="1200"/>
+              </a:spcBef>
+            </a:pPr>
+            <a:r>
+              <a:rPr lang="en-US" dirty="0"/>
+              <a:t>Interface Concepts</a:t>
+            </a:r>
+          </a:p>
+          <a:p>
+            <a:pPr lvl="1">
+              <a:spcBef>
+                <a:spcPts val="600"/>
+              </a:spcBef>
+            </a:pPr>
+            <a:r>
+              <a:rPr lang="en-US" dirty="0"/>
+              <a:t>Multiple Interfaces</a:t>
+            </a:r>
+          </a:p>
+          <a:p>
+            <a:pPr lvl="1">
+              <a:spcBef>
+                <a:spcPts val="600"/>
+              </a:spcBef>
+            </a:pPr>
+            <a:r>
+              <a:rPr lang="en-US" dirty="0"/>
+              <a:t>Resources</a:t>
+            </a:r>
+          </a:p>
+          <a:p>
+            <a:pPr lvl="1">
+              <a:spcBef>
+                <a:spcPts val="600"/>
+              </a:spcBef>
+            </a:pPr>
+            <a:r>
+              <a:rPr lang="en-US" dirty="0"/>
+              <a:t>Operations, Events, and Properties</a:t>
+            </a:r>
+          </a:p>
+          <a:p>
+            <a:pPr lvl="1">
+              <a:spcBef>
+                <a:spcPts val="600"/>
+              </a:spcBef>
+            </a:pPr>
+            <a:r>
+              <a:rPr lang="en-US" dirty="0"/>
+              <a:t>Interface Evolution</a:t>
+            </a:r>
+          </a:p>
+          <a:p>
+            <a:pPr>
+              <a:spcBef>
+                <a:spcPts val="1200"/>
+              </a:spcBef>
+            </a:pPr>
+            <a:r>
+              <a:rPr lang="en-US" dirty="0"/>
+              <a:t>Designing an Interface</a:t>
+            </a:r>
+          </a:p>
+          <a:p>
+            <a:pPr lvl="1">
+              <a:spcBef>
+                <a:spcPts val="600"/>
+              </a:spcBef>
+            </a:pPr>
+            <a:r>
+              <a:rPr lang="en-US" dirty="0"/>
+              <a:t>Interface Scope</a:t>
+            </a:r>
+          </a:p>
+          <a:p>
+            <a:pPr lvl="1">
+              <a:spcBef>
+                <a:spcPts val="600"/>
+              </a:spcBef>
+            </a:pPr>
+            <a:r>
+              <a:rPr lang="en-US" dirty="0"/>
+              <a:t>Interaction Styles</a:t>
+            </a:r>
+          </a:p>
+          <a:p>
+            <a:pPr lvl="1">
+              <a:spcBef>
+                <a:spcPts val="600"/>
+              </a:spcBef>
+            </a:pPr>
+            <a:r>
+              <a:rPr lang="en-US" dirty="0"/>
+              <a:t>Representation and Structure of Exchanged Data</a:t>
+            </a:r>
+          </a:p>
+          <a:p>
+            <a:pPr>
+              <a:spcBef>
+                <a:spcPts val="1200"/>
+              </a:spcBef>
+            </a:pPr>
+            <a:r>
+              <a:rPr lang="en-US" dirty="0"/>
+              <a:t>Documenting the Interface</a:t>
+            </a:r>
+          </a:p>
+          <a:p>
+            <a:pPr>
+              <a:spcBef>
+                <a:spcPts val="1200"/>
+              </a:spcBef>
+            </a:pPr>
+            <a:r>
+              <a:rPr lang="en-US" dirty="0"/>
+              <a:t>Summary</a:t>
+            </a:r>
           </a:p>
         </p:txBody>
       </p:sp>
@@ -6746,7 +6908,7 @@
           <a:p>
             <a:r>
               <a:rPr lang="en-US" dirty="0"/>
-              <a:t>15.1 Interface Concepts: Multiple Interfaces</a:t>
+              <a:t>Interface Concepts: Multiple Interfaces</a:t>
             </a:r>
           </a:p>
         </p:txBody>

</xml_diff>